<commit_message>
Pitch deck: readable income chart, inference-only costs with scale-up, fuller roadmap; add presenter notes
Slide 6 uses horizontal bars so every rupee label is readable. Slide 8
shows inference cost only (hosting removed) and what it costs at 1,000,
1 lakh and 10 lakh families a month, from measured per-question and
per-estimate costs. Slide 10 gives each phase a goal and a target.
Slide 5 records that Hindi is done.

Presenter notes PDF: each slide as a heading with what it says, how to
explain it, where its numbers come from, and its short forms; a full
glossary at the end. Rebuild with python src/build_notes.py.

Co-Authored-By: Claude Opus 5.5 <noreply@anthropic.com>
</commit_message>
<xml_diff>
--- a/presentation deck/ClaimCast - Pitch Deck.pptx
+++ b/presentation deck/ClaimCast - Pitch Deck.pptx
@@ -132,7 +132,7 @@
     <c:autoTitleDeleted val="0"/>
     <c:plotArea>
       <c:barChart>
-        <c:barDir val="col"/>
+        <c:barDir val="bar"/>
         <c:grouping val="clustered"/>
         <c:ser>
           <c:idx val="0"/>
@@ -275,9 +275,9 @@
             <a:lstStyle/>
             <a:p>
               <a:pPr>
-                <a:defRPr sz="900">
+                <a:defRPr sz="1100" b="1">
                   <a:solidFill>
-                    <a:srgbClr val="2B3138"/>
+                    <a:srgbClr val="14181C"/>
                   </a:solidFill>
                   <a:latin typeface="Arial"/>
                 </a:defRPr>
@@ -293,17 +293,18 @@
           <c:showBubbleSize val="0"/>
           <c:showLeaderLines val="1"/>
         </c:dLbls>
-        <c:gapWidth val="60"/>
+        <c:gapWidth val="45"/>
+        <c:overlap val="-8"/>
         <c:axId val="-2068027336"/>
         <c:axId val="-2113994440"/>
       </c:barChart>
       <c:catAx>
         <c:axId val="-2068027336"/>
         <c:scaling>
-          <c:orientation val="minMax"/>
+          <c:orientation val="maxMin"/>
         </c:scaling>
         <c:delete val="0"/>
-        <c:axPos val="b"/>
+        <c:axPos val="l"/>
         <c:majorTickMark val="out"/>
         <c:minorTickMark val="none"/>
         <c:tickLblPos val="nextTo"/>
@@ -319,7 +320,7 @@
           <a:lstStyle/>
           <a:p>
             <a:pPr>
-              <a:defRPr sz="1050">
+              <a:defRPr sz="1100">
                 <a:latin typeface="Arial"/>
               </a:defRPr>
             </a:pPr>
@@ -334,9 +335,12 @@
       </c:catAx>
       <c:valAx>
         <c:axId val="-2113994440"/>
-        <c:scaling/>
+        <c:scaling>
+          <c:max val="100000.0"/>
+          <c:min val="0.0"/>
+        </c:scaling>
         <c:delete/>
-        <c:axPos val="l"/>
+        <c:axPos val="b"/>
         <c:majorTickMark val="out"/>
         <c:minorTickMark val="none"/>
         <c:tickLblPos val="nextTo"/>
@@ -842,7 +846,7 @@
           <a:lstStyle/>
           <a:p>
             <a:r>
-              <a:t>Roadmap dates are targets, not commitments.</a:t>
+              <a:t>Roadmap dates and targets are goals, not commitments. DPDP Act: Digital Personal Data Protection Act, 2023. ABDM: Ayushman Bharat Digital Mission, the national digital health records programme.</a:t>
             </a:r>
           </a:p>
         </p:txBody>
@@ -1332,7 +1336,7 @@
           <a:lstStyle/>
           <a:p>
             <a:r>
-              <a:t>Hosting: infra/deploy.md (Cloud Run + always-free e2-micro Postgres; Artifact Registry ~₹9–15/month). Chat: OpenRouter usage rose about $0.005 over ~11 test calls, under 5 paise each. Retrain: the full artifact build ran in 4.6 s on a MacBook. The ₹78,400 is the prototype's example case.</a:t>
+              <a:t>Inference cost only; hosting, storage and staff are not included. Chat: OpenRouter usage rose about $0.005 over ~11 test calls, about $0.0005 each. Bill estimate: the ML service answered in 0.9-2.7 ms; priced at 2 ms of Cloud Run CPU ($0.000024 per vCPU-second). $1 is taken as ₹88. The ₹78,400 is the prototype's example case.</a:t>
             </a:r>
           </a:p>
         </p:txBody>
@@ -4452,8 +4456,8 @@
         </p:nvSpPr>
         <p:spPr>
           <a:xfrm>
-            <a:off x="548640" y="1325880"/>
-            <a:ext cx="3520440" cy="3611880"/>
+            <a:off x="548640" y="1188720"/>
+            <a:ext cx="3520440" cy="4160520"/>
           </a:xfrm>
           <a:prstGeom prst="roundRect">
             <a:avLst>
@@ -4500,7 +4504,7 @@
         </p:nvSpPr>
         <p:spPr>
           <a:xfrm>
-            <a:off x="822959" y="1572768"/>
+            <a:off x="822959" y="1389888"/>
             <a:ext cx="475488" cy="475488"/>
           </a:xfrm>
           <a:prstGeom prst="ellipse">
@@ -4553,8 +4557,8 @@
         </p:nvSpPr>
         <p:spPr>
           <a:xfrm>
-            <a:off x="1444752" y="1645920"/>
-            <a:ext cx="2560320" cy="411480"/>
+            <a:off x="1444752" y="1371600"/>
+            <a:ext cx="2560320" cy="365760"/>
           </a:xfrm>
           <a:prstGeom prst="rect">
             <a:avLst/>
@@ -4595,8 +4599,50 @@
         </p:nvSpPr>
         <p:spPr>
           <a:xfrm>
-            <a:off x="822959" y="2377440"/>
-            <a:ext cx="3017520" cy="2468880"/>
+            <a:off x="1444752" y="1719072"/>
+            <a:ext cx="2560320" cy="274320"/>
+          </a:xfrm>
+          <a:prstGeom prst="rect">
+            <a:avLst/>
+          </a:prstGeom>
+          <a:noFill/>
+        </p:spPr>
+        <p:txBody>
+          <a:bodyPr wrap="square" lIns="0" rIns="0" tIns="0" bIns="0" anchor="t">
+            <a:spAutoFit/>
+          </a:bodyPr>
+          <a:lstStyle/>
+          <a:p>
+            <a:pPr algn="l">
+              <a:spcBef>
+                <a:spcPts val="0"/>
+              </a:spcBef>
+              <a:spcAft>
+                <a:spcPts val="0"/>
+              </a:spcAft>
+            </a:pPr>
+            <a:r>
+              <a:rPr sz="1150" b="1" i="0">
+                <a:solidFill>
+                  <a:srgbClr val="005EB8"/>
+                </a:solidFill>
+                <a:latin typeface="Arial"/>
+              </a:rPr>
+              <a:t>Prove it helps families</a:t>
+            </a:r>
+          </a:p>
+        </p:txBody>
+      </p:sp>
+      <p:sp>
+        <p:nvSpPr>
+          <p:cNvPr id="9" name="TextBox 8"/>
+          <p:cNvSpPr txBox="1"/>
+          <p:nvPr/>
+        </p:nvSpPr>
+        <p:spPr>
+          <a:xfrm>
+            <a:off x="822959" y="2240280"/>
+            <a:ext cx="3017520" cy="2514600"/>
           </a:xfrm>
           <a:prstGeom prst="rect">
             <a:avLst/>
@@ -4614,11 +4660,11 @@
                 <a:spcPct val="112000"/>
               </a:lnSpc>
               <a:spcAft>
-                <a:spcPts val="1200"/>
-              </a:spcAft>
-            </a:pPr>
-            <a:r>
-              <a:rPr sz="1400" b="1">
+                <a:spcPts val="700"/>
+              </a:spcAft>
+            </a:pPr>
+            <a:r>
+              <a:rPr sz="1200" b="1">
                 <a:solidFill>
                   <a:srgbClr val="005EB8"/>
                 </a:solidFill>
@@ -4627,13 +4673,13 @@
               <a:t>•  </a:t>
             </a:r>
             <a:r>
-              <a:rPr sz="1400">
+              <a:rPr sz="1200">
                 <a:solidFill>
                   <a:srgbClr val="2B3138"/>
                 </a:solidFill>
                 <a:latin typeface="Arial"/>
               </a:rPr>
-              <a:t>Study with 20 real families</a:t>
+              <a:t>Study with 20 real families at an admission desk</a:t>
             </a:r>
           </a:p>
           <a:p>
@@ -4642,11 +4688,11 @@
                 <a:spcPct val="112000"/>
               </a:lnSpc>
               <a:spcAft>
-                <a:spcPts val="1200"/>
-              </a:spcAft>
-            </a:pPr>
-            <a:r>
-              <a:rPr sz="1400" b="1">
+                <a:spcPts val="700"/>
+              </a:spcAft>
+            </a:pPr>
+            <a:r>
+              <a:rPr sz="1200" b="1">
                 <a:solidFill>
                   <a:srgbClr val="005EB8"/>
                 </a:solidFill>
@@ -4655,13 +4701,13 @@
               <a:t>•  </a:t>
             </a:r>
             <a:r>
-              <a:rPr sz="1400">
+              <a:rPr sz="1200">
                 <a:solidFill>
                   <a:srgbClr val="2B3138"/>
                 </a:solidFill>
                 <a:latin typeface="Arial"/>
               </a:rPr>
-              <a:t>Hindi and regional languages</a:t>
+              <a:t>More Indian languages after Hindi: Tamil, Bengali, Marathi</a:t>
             </a:r>
           </a:p>
           <a:p>
@@ -4670,11 +4716,11 @@
                 <a:spcPct val="112000"/>
               </a:lnSpc>
               <a:spcAft>
-                <a:spcPts val="1200"/>
-              </a:spcAft>
-            </a:pPr>
-            <a:r>
-              <a:rPr sz="1400" b="1">
+                <a:spcPts val="700"/>
+              </a:spcAft>
+            </a:pPr>
+            <a:r>
+              <a:rPr sz="1200" b="1">
                 <a:solidFill>
                   <a:srgbClr val="005EB8"/>
                 </a:solidFill>
@@ -4683,27 +4729,171 @@
               <a:t>•  </a:t>
             </a:r>
             <a:r>
-              <a:rPr sz="1400">
+              <a:rPr sz="1200">
                 <a:solidFill>
                   <a:srgbClr val="2B3138"/>
                 </a:solidFill>
                 <a:latin typeface="Arial"/>
               </a:rPr>
-              <a:t>Ask by voice or WhatsApp</a:t>
-            </a:r>
-          </a:p>
-        </p:txBody>
-      </p:sp>
-      <p:sp>
-        <p:nvSpPr>
-          <p:cNvPr id="9" name="Rounded Rectangle 8"/>
+              <a:t>Ask by voice, and on WhatsApp</a:t>
+            </a:r>
+          </a:p>
+          <a:p>
+            <a:pPr>
+              <a:lnSpc>
+                <a:spcPct val="112000"/>
+              </a:lnSpc>
+              <a:spcAft>
+                <a:spcPts val="700"/>
+              </a:spcAft>
+            </a:pPr>
+            <a:r>
+              <a:rPr sz="1200" b="1">
+                <a:solidFill>
+                  <a:srgbClr val="005EB8"/>
+                </a:solidFill>
+                <a:latin typeface="Arial"/>
+              </a:rPr>
+              <a:t>•  </a:t>
+            </a:r>
+            <a:r>
+              <a:rPr sz="1200">
+                <a:solidFill>
+                  <a:srgbClr val="2B3138"/>
+                </a:solidFill>
+                <a:latin typeface="Arial"/>
+              </a:rPr>
+              <a:t>Collect the first 50 real bills so the estimator starts learning</a:t>
+            </a:r>
+          </a:p>
+          <a:p>
+            <a:pPr>
+              <a:lnSpc>
+                <a:spcPct val="112000"/>
+              </a:lnSpc>
+              <a:spcAft>
+                <a:spcPts val="700"/>
+              </a:spcAft>
+            </a:pPr>
+            <a:r>
+              <a:rPr sz="1200" b="1">
+                <a:solidFill>
+                  <a:srgbClr val="005EB8"/>
+                </a:solidFill>
+                <a:latin typeface="Arial"/>
+              </a:rPr>
+              <a:t>•  </a:t>
+            </a:r>
+            <a:r>
+              <a:rPr sz="1200">
+                <a:solidFill>
+                  <a:srgbClr val="2B3138"/>
+                </a:solidFill>
+                <a:latin typeface="Arial"/>
+              </a:rPr>
+              <a:t>Proper logins for the team side</a:t>
+            </a:r>
+          </a:p>
+        </p:txBody>
+      </p:sp>
+      <p:sp>
+        <p:nvSpPr>
+          <p:cNvPr id="10" name="Rounded Rectangle 9"/>
           <p:cNvSpPr/>
           <p:nvPr/>
         </p:nvSpPr>
         <p:spPr>
           <a:xfrm>
-            <a:off x="4343400" y="1325880"/>
-            <a:ext cx="3520440" cy="3611880"/>
+            <a:off x="822959" y="4828032"/>
+            <a:ext cx="2971800" cy="384048"/>
+          </a:xfrm>
+          <a:prstGeom prst="roundRect">
+            <a:avLst>
+              <a:gd name="adj" fmla="val 30000"/>
+            </a:avLst>
+          </a:prstGeom>
+          <a:solidFill>
+            <a:srgbClr val="E8F1FA"/>
+          </a:solidFill>
+          <a:ln>
+            <a:noFill/>
+          </a:ln>
+          <a:effectLst/>
+        </p:spPr>
+        <p:style>
+          <a:lnRef idx="1">
+            <a:schemeClr val="accent1"/>
+          </a:lnRef>
+          <a:fillRef idx="3">
+            <a:schemeClr val="accent1"/>
+          </a:fillRef>
+          <a:effectRef idx="2">
+            <a:schemeClr val="accent1"/>
+          </a:effectRef>
+          <a:fontRef idx="minor">
+            <a:schemeClr val="lt1"/>
+          </a:fontRef>
+        </p:style>
+        <p:txBody>
+          <a:bodyPr rtlCol="0" anchor="ctr"/>
+          <a:lstStyle/>
+          <a:p>
+            <a:pPr algn="ctr"/>
+          </a:p>
+        </p:txBody>
+      </p:sp>
+      <p:sp>
+        <p:nvSpPr>
+          <p:cNvPr id="11" name="TextBox 10"/>
+          <p:cNvSpPr txBox="1"/>
+          <p:nvPr/>
+        </p:nvSpPr>
+        <p:spPr>
+          <a:xfrm>
+            <a:off x="822959" y="4828032"/>
+            <a:ext cx="2971800" cy="384048"/>
+          </a:xfrm>
+          <a:prstGeom prst="rect">
+            <a:avLst/>
+          </a:prstGeom>
+          <a:noFill/>
+        </p:spPr>
+        <p:txBody>
+          <a:bodyPr wrap="square" lIns="0" rIns="0" tIns="0" bIns="0" anchor="ctr">
+            <a:spAutoFit/>
+          </a:bodyPr>
+          <a:lstStyle/>
+          <a:p>
+            <a:pPr algn="ctr">
+              <a:spcBef>
+                <a:spcPts val="0"/>
+              </a:spcBef>
+              <a:spcAft>
+                <a:spcPts val="0"/>
+              </a:spcAft>
+            </a:pPr>
+            <a:r>
+              <a:rPr sz="1100" b="1" i="0">
+                <a:solidFill>
+                  <a:srgbClr val="005EB8"/>
+                </a:solidFill>
+                <a:latin typeface="Arial"/>
+              </a:rPr>
+              <a:t>Target: usability score 70+</a:t>
+            </a:r>
+          </a:p>
+        </p:txBody>
+      </p:sp>
+      <p:sp>
+        <p:nvSpPr>
+          <p:cNvPr id="12" name="Rounded Rectangle 11"/>
+          <p:cNvSpPr/>
+          <p:nvPr/>
+        </p:nvSpPr>
+        <p:spPr>
+          <a:xfrm>
+            <a:off x="4343400" y="1188720"/>
+            <a:ext cx="3520440" cy="4160520"/>
           </a:xfrm>
           <a:prstGeom prst="roundRect">
             <a:avLst>
@@ -4744,13 +4934,13 @@
       </p:sp>
       <p:sp>
         <p:nvSpPr>
-          <p:cNvPr id="10" name="Oval 9"/>
+          <p:cNvPr id="13" name="Oval 12"/>
           <p:cNvSpPr/>
           <p:nvPr/>
         </p:nvSpPr>
         <p:spPr>
           <a:xfrm>
-            <a:off x="4617720" y="1572768"/>
+            <a:off x="4617720" y="1389888"/>
             <a:ext cx="475488" cy="475488"/>
           </a:xfrm>
           <a:prstGeom prst="ellipse">
@@ -4797,14 +4987,14 @@
       </p:sp>
       <p:sp>
         <p:nvSpPr>
-          <p:cNvPr id="11" name="TextBox 10"/>
+          <p:cNvPr id="14" name="TextBox 13"/>
           <p:cNvSpPr txBox="1"/>
           <p:nvPr/>
         </p:nvSpPr>
         <p:spPr>
           <a:xfrm>
-            <a:off x="5239512" y="1645920"/>
-            <a:ext cx="2560320" cy="411480"/>
+            <a:off x="5239512" y="1371600"/>
+            <a:ext cx="2560320" cy="365760"/>
           </a:xfrm>
           <a:prstGeom prst="rect">
             <a:avLst/>
@@ -4839,14 +5029,56 @@
       </p:sp>
       <p:sp>
         <p:nvSpPr>
-          <p:cNvPr id="12" name="TextBox 11"/>
+          <p:cNvPr id="15" name="TextBox 14"/>
           <p:cNvSpPr txBox="1"/>
           <p:nvPr/>
         </p:nvSpPr>
         <p:spPr>
           <a:xfrm>
-            <a:off x="4617720" y="2377440"/>
-            <a:ext cx="3017520" cy="2468880"/>
+            <a:off x="5239512" y="1719072"/>
+            <a:ext cx="2560320" cy="274320"/>
+          </a:xfrm>
+          <a:prstGeom prst="rect">
+            <a:avLst/>
+          </a:prstGeom>
+          <a:noFill/>
+        </p:spPr>
+        <p:txBody>
+          <a:bodyPr wrap="square" lIns="0" rIns="0" tIns="0" bIns="0" anchor="t">
+            <a:spAutoFit/>
+          </a:bodyPr>
+          <a:lstStyle/>
+          <a:p>
+            <a:pPr algn="l">
+              <a:spcBef>
+                <a:spcPts val="0"/>
+              </a:spcBef>
+              <a:spcAft>
+                <a:spcPts val="0"/>
+              </a:spcAft>
+            </a:pPr>
+            <a:r>
+              <a:rPr sz="1150" b="1" i="0">
+                <a:solidFill>
+                  <a:srgbClr val="005EB8"/>
+                </a:solidFill>
+                <a:latin typeface="Arial"/>
+              </a:rPr>
+              <a:t>Real prices, real bills</a:t>
+            </a:r>
+          </a:p>
+        </p:txBody>
+      </p:sp>
+      <p:sp>
+        <p:nvSpPr>
+          <p:cNvPr id="16" name="TextBox 15"/>
+          <p:cNvSpPr txBox="1"/>
+          <p:nvPr/>
+        </p:nvSpPr>
+        <p:spPr>
+          <a:xfrm>
+            <a:off x="4617720" y="2240280"/>
+            <a:ext cx="3017520" cy="2514600"/>
           </a:xfrm>
           <a:prstGeom prst="rect">
             <a:avLst/>
@@ -4864,11 +5096,11 @@
                 <a:spcPct val="112000"/>
               </a:lnSpc>
               <a:spcAft>
-                <a:spcPts val="1200"/>
-              </a:spcAft>
-            </a:pPr>
-            <a:r>
-              <a:rPr sz="1400" b="1">
+                <a:spcPts val="700"/>
+              </a:spcAft>
+            </a:pPr>
+            <a:r>
+              <a:rPr sz="1200" b="1">
                 <a:solidFill>
                   <a:srgbClr val="005EB8"/>
                 </a:solidFill>
@@ -4877,13 +5109,13 @@
               <a:t>•  </a:t>
             </a:r>
             <a:r>
-              <a:rPr sz="1400">
+              <a:rPr sz="1200">
                 <a:solidFill>
                   <a:srgbClr val="2B3138"/>
                 </a:solidFill>
                 <a:latin typeface="Arial"/>
               </a:rPr>
-              <a:t>Partner hospitals share real prices and bills</a:t>
+              <a:t>Partner hospitals share their price lists and final bills</a:t>
             </a:r>
           </a:p>
           <a:p>
@@ -4892,11 +5124,11 @@
                 <a:spcPct val="112000"/>
               </a:lnSpc>
               <a:spcAft>
-                <a:spcPts val="1200"/>
-              </a:spcAft>
-            </a:pPr>
-            <a:r>
-              <a:rPr sz="1400" b="1">
+                <a:spcPts val="700"/>
+              </a:spcAft>
+            </a:pPr>
+            <a:r>
+              <a:rPr sz="1200" b="1">
                 <a:solidFill>
                   <a:srgbClr val="005EB8"/>
                 </a:solidFill>
@@ -4905,13 +5137,13 @@
               <a:t>•  </a:t>
             </a:r>
             <a:r>
-              <a:rPr sz="1400">
+              <a:rPr sz="1200">
                 <a:solidFill>
                   <a:srgbClr val="2B3138"/>
                 </a:solidFill>
                 <a:latin typeface="Arial"/>
               </a:rPr>
-              <a:t>The estimator learns from real bills</a:t>
+              <a:t>Read the policy formats of India’s 20 largest insurers</a:t>
             </a:r>
           </a:p>
           <a:p>
@@ -4920,11 +5152,11 @@
                 <a:spcPct val="112000"/>
               </a:lnSpc>
               <a:spcAft>
-                <a:spcPts val="1200"/>
-              </a:spcAft>
-            </a:pPr>
-            <a:r>
-              <a:rPr sz="1400" b="1">
+                <a:spcPts val="700"/>
+              </a:spcAft>
+            </a:pPr>
+            <a:r>
+              <a:rPr sz="1200" b="1">
                 <a:solidFill>
                   <a:srgbClr val="005EB8"/>
                 </a:solidFill>
@@ -4933,7 +5165,7 @@
               <a:t>•  </a:t>
             </a:r>
             <a:r>
-              <a:rPr sz="1400">
+              <a:rPr sz="1200">
                 <a:solidFill>
                   <a:srgbClr val="2B3138"/>
                 </a:solidFill>
@@ -4942,18 +5174,134 @@
               <a:t>Connect to insurers’ cashless approval</a:t>
             </a:r>
           </a:p>
-        </p:txBody>
-      </p:sp>
-      <p:sp>
-        <p:nvSpPr>
-          <p:cNvPr id="13" name="Rounded Rectangle 12"/>
+          <a:p>
+            <a:pPr>
+              <a:lnSpc>
+                <a:spcPct val="112000"/>
+              </a:lnSpc>
+              <a:spcAft>
+                <a:spcPts val="700"/>
+              </a:spcAft>
+            </a:pPr>
+            <a:r>
+              <a:rPr sz="1200" b="1">
+                <a:solidFill>
+                  <a:srgbClr val="005EB8"/>
+                </a:solidFill>
+                <a:latin typeface="Arial"/>
+              </a:rPr>
+              <a:t>•  </a:t>
+            </a:r>
+            <a:r>
+              <a:rPr sz="1200">
+                <a:solidFill>
+                  <a:srgbClr val="2B3138"/>
+                </a:solidFill>
+                <a:latin typeface="Arial"/>
+              </a:rPr>
+              <a:t>Price every one of the 1,949 government treatment packages on the path</a:t>
+            </a:r>
+          </a:p>
+        </p:txBody>
+      </p:sp>
+      <p:sp>
+        <p:nvSpPr>
+          <p:cNvPr id="17" name="Rounded Rectangle 16"/>
           <p:cNvSpPr/>
           <p:nvPr/>
         </p:nvSpPr>
         <p:spPr>
           <a:xfrm>
-            <a:off x="8138160" y="1325880"/>
-            <a:ext cx="3520440" cy="3611880"/>
+            <a:off x="4617720" y="4828032"/>
+            <a:ext cx="2971800" cy="384048"/>
+          </a:xfrm>
+          <a:prstGeom prst="roundRect">
+            <a:avLst>
+              <a:gd name="adj" fmla="val 30000"/>
+            </a:avLst>
+          </a:prstGeom>
+          <a:solidFill>
+            <a:srgbClr val="E8F1FA"/>
+          </a:solidFill>
+          <a:ln>
+            <a:noFill/>
+          </a:ln>
+          <a:effectLst/>
+        </p:spPr>
+        <p:style>
+          <a:lnRef idx="1">
+            <a:schemeClr val="accent1"/>
+          </a:lnRef>
+          <a:fillRef idx="3">
+            <a:schemeClr val="accent1"/>
+          </a:fillRef>
+          <a:effectRef idx="2">
+            <a:schemeClr val="accent1"/>
+          </a:effectRef>
+          <a:fontRef idx="minor">
+            <a:schemeClr val="lt1"/>
+          </a:fontRef>
+        </p:style>
+        <p:txBody>
+          <a:bodyPr rtlCol="0" anchor="ctr"/>
+          <a:lstStyle/>
+          <a:p>
+            <a:pPr algn="ctr"/>
+          </a:p>
+        </p:txBody>
+      </p:sp>
+      <p:sp>
+        <p:nvSpPr>
+          <p:cNvPr id="18" name="TextBox 17"/>
+          <p:cNvSpPr txBox="1"/>
+          <p:nvPr/>
+        </p:nvSpPr>
+        <p:spPr>
+          <a:xfrm>
+            <a:off x="4617720" y="4828032"/>
+            <a:ext cx="2971800" cy="384048"/>
+          </a:xfrm>
+          <a:prstGeom prst="rect">
+            <a:avLst/>
+          </a:prstGeom>
+          <a:noFill/>
+        </p:spPr>
+        <p:txBody>
+          <a:bodyPr wrap="square" lIns="0" rIns="0" tIns="0" bIns="0" anchor="ctr">
+            <a:spAutoFit/>
+          </a:bodyPr>
+          <a:lstStyle/>
+          <a:p>
+            <a:pPr algn="ctr">
+              <a:spcBef>
+                <a:spcPts val="0"/>
+              </a:spcBef>
+              <a:spcAft>
+                <a:spcPts val="0"/>
+              </a:spcAft>
+            </a:pPr>
+            <a:r>
+              <a:rPr sz="1100" b="1" i="0">
+                <a:solidFill>
+                  <a:srgbClr val="005EB8"/>
+                </a:solidFill>
+                <a:latin typeface="Arial"/>
+              </a:rPr>
+              <a:t>Target: estimate within 15% of the real bill</a:t>
+            </a:r>
+          </a:p>
+        </p:txBody>
+      </p:sp>
+      <p:sp>
+        <p:nvSpPr>
+          <p:cNvPr id="19" name="Rounded Rectangle 18"/>
+          <p:cNvSpPr/>
+          <p:nvPr/>
+        </p:nvSpPr>
+        <p:spPr>
+          <a:xfrm>
+            <a:off x="8138160" y="1188720"/>
+            <a:ext cx="3520440" cy="4160520"/>
           </a:xfrm>
           <a:prstGeom prst="roundRect">
             <a:avLst>
@@ -4994,13 +5342,13 @@
       </p:sp>
       <p:sp>
         <p:nvSpPr>
-          <p:cNvPr id="14" name="Oval 13"/>
+          <p:cNvPr id="20" name="Oval 19"/>
           <p:cNvSpPr/>
           <p:nvPr/>
         </p:nvSpPr>
         <p:spPr>
           <a:xfrm>
-            <a:off x="8412480" y="1572768"/>
+            <a:off x="8412480" y="1389888"/>
             <a:ext cx="475488" cy="475488"/>
           </a:xfrm>
           <a:prstGeom prst="ellipse">
@@ -5047,14 +5395,14 @@
       </p:sp>
       <p:sp>
         <p:nvSpPr>
-          <p:cNvPr id="15" name="TextBox 14"/>
+          <p:cNvPr id="21" name="TextBox 20"/>
           <p:cNvSpPr txBox="1"/>
           <p:nvPr/>
         </p:nvSpPr>
         <p:spPr>
           <a:xfrm>
-            <a:off x="9034272" y="1645920"/>
-            <a:ext cx="2560320" cy="411480"/>
+            <a:off x="9034272" y="1371600"/>
+            <a:ext cx="2560320" cy="365760"/>
           </a:xfrm>
           <a:prstGeom prst="rect">
             <a:avLst/>
@@ -5089,14 +5437,56 @@
       </p:sp>
       <p:sp>
         <p:nvSpPr>
-          <p:cNvPr id="16" name="TextBox 15"/>
+          <p:cNvPr id="22" name="TextBox 21"/>
           <p:cNvSpPr txBox="1"/>
           <p:nvPr/>
         </p:nvSpPr>
         <p:spPr>
           <a:xfrm>
-            <a:off x="8412480" y="2377440"/>
-            <a:ext cx="3017520" cy="2468880"/>
+            <a:off x="9034272" y="1719072"/>
+            <a:ext cx="2560320" cy="274320"/>
+          </a:xfrm>
+          <a:prstGeom prst="rect">
+            <a:avLst/>
+          </a:prstGeom>
+          <a:noFill/>
+        </p:spPr>
+        <p:txBody>
+          <a:bodyPr wrap="square" lIns="0" rIns="0" tIns="0" bIns="0" anchor="t">
+            <a:spAutoFit/>
+          </a:bodyPr>
+          <a:lstStyle/>
+          <a:p>
+            <a:pPr algn="l">
+              <a:spcBef>
+                <a:spcPts val="0"/>
+              </a:spcBef>
+              <a:spcAft>
+                <a:spcPts val="0"/>
+              </a:spcAft>
+            </a:pPr>
+            <a:r>
+              <a:rPr sz="1150" b="1" i="0">
+                <a:solidFill>
+                  <a:srgbClr val="005EB8"/>
+                </a:solidFill>
+                <a:latin typeface="Arial"/>
+              </a:rPr>
+              <a:t>Ready for real patients</a:t>
+            </a:r>
+          </a:p>
+        </p:txBody>
+      </p:sp>
+      <p:sp>
+        <p:nvSpPr>
+          <p:cNvPr id="23" name="TextBox 22"/>
+          <p:cNvSpPr txBox="1"/>
+          <p:nvPr/>
+        </p:nvSpPr>
+        <p:spPr>
+          <a:xfrm>
+            <a:off x="8412480" y="2240280"/>
+            <a:ext cx="3017520" cy="2514600"/>
           </a:xfrm>
           <a:prstGeom prst="rect">
             <a:avLst/>
@@ -5114,11 +5504,11 @@
                 <a:spcPct val="112000"/>
               </a:lnSpc>
               <a:spcAft>
-                <a:spcPts val="1200"/>
-              </a:spcAft>
-            </a:pPr>
-            <a:r>
-              <a:rPr sz="1400" b="1">
+                <a:spcPts val="700"/>
+              </a:spcAft>
+            </a:pPr>
+            <a:r>
+              <a:rPr sz="1200" b="1">
                 <a:solidFill>
                   <a:srgbClr val="005EB8"/>
                 </a:solidFill>
@@ -5127,7 +5517,7 @@
               <a:t>•  </a:t>
             </a:r>
             <a:r>
-              <a:rPr sz="1400">
+              <a:rPr sz="1200">
                 <a:solidFill>
                   <a:srgbClr val="2B3138"/>
                 </a:solidFill>
@@ -5142,11 +5532,11 @@
                 <a:spcPct val="112000"/>
               </a:lnSpc>
               <a:spcAft>
-                <a:spcPts val="1200"/>
-              </a:spcAft>
-            </a:pPr>
-            <a:r>
-              <a:rPr sz="1400" b="1">
+                <a:spcPts val="700"/>
+              </a:spcAft>
+            </a:pPr>
+            <a:r>
+              <a:rPr sz="1200" b="1">
                 <a:solidFill>
                   <a:srgbClr val="005EB8"/>
                 </a:solidFill>
@@ -5155,7 +5545,7 @@
               <a:t>•  </a:t>
             </a:r>
             <a:r>
-              <a:rPr sz="1400">
+              <a:rPr sz="1200">
                 <a:solidFill>
                   <a:srgbClr val="2B3138"/>
                 </a:solidFill>
@@ -5170,11 +5560,11 @@
                 <a:spcPct val="112000"/>
               </a:lnSpc>
               <a:spcAft>
-                <a:spcPts val="1200"/>
-              </a:spcAft>
-            </a:pPr>
-            <a:r>
-              <a:rPr sz="1400" b="1">
+                <a:spcPts val="700"/>
+              </a:spcAft>
+            </a:pPr>
+            <a:r>
+              <a:rPr sz="1200" b="1">
                 <a:solidFill>
                   <a:srgbClr val="005EB8"/>
                 </a:solidFill>
@@ -5183,31 +5573,59 @@
               <a:t>•  </a:t>
             </a:r>
             <a:r>
-              <a:rPr sz="1400">
+              <a:rPr sz="1200">
                 <a:solidFill>
                   <a:srgbClr val="2B3138"/>
                 </a:solidFill>
                 <a:latin typeface="Arial"/>
               </a:rPr>
-              <a:t>Strong privacy, consent and security for real data</a:t>
-            </a:r>
-          </a:p>
-        </p:txBody>
-      </p:sp>
-      <p:sp>
-        <p:nvSpPr>
-          <p:cNvPr id="17" name="Rounded Rectangle 16"/>
+              <a:t>Privacy and consent under India’s DPDP Act, 2023</a:t>
+            </a:r>
+          </a:p>
+          <a:p>
+            <a:pPr>
+              <a:lnSpc>
+                <a:spcPct val="112000"/>
+              </a:lnSpc>
+              <a:spcAft>
+                <a:spcPts val="700"/>
+              </a:spcAft>
+            </a:pPr>
+            <a:r>
+              <a:rPr sz="1200" b="1">
+                <a:solidFill>
+                  <a:srgbClr val="005EB8"/>
+                </a:solidFill>
+                <a:latin typeface="Arial"/>
+              </a:rPr>
+              <a:t>•  </a:t>
+            </a:r>
+            <a:r>
+              <a:rPr sz="1200">
+                <a:solidFill>
+                  <a:srgbClr val="2B3138"/>
+                </a:solidFill>
+                <a:latin typeface="Arial"/>
+              </a:rPr>
+              <a:t>Link to Ayushman Bharat Digital Mission health records, with consent</a:t>
+            </a:r>
+          </a:p>
+        </p:txBody>
+      </p:sp>
+      <p:sp>
+        <p:nvSpPr>
+          <p:cNvPr id="24" name="Rounded Rectangle 23"/>
           <p:cNvSpPr/>
           <p:nvPr/>
         </p:nvSpPr>
         <p:spPr>
           <a:xfrm>
-            <a:off x="548640" y="5257800"/>
-            <a:ext cx="11091672" cy="914400"/>
+            <a:off x="8412480" y="4828032"/>
+            <a:ext cx="2971800" cy="384048"/>
           </a:xfrm>
           <a:prstGeom prst="roundRect">
             <a:avLst>
-              <a:gd name="adj" fmla="val 6000"/>
+              <a:gd name="adj" fmla="val 30000"/>
             </a:avLst>
           </a:prstGeom>
           <a:solidFill>
@@ -5242,14 +5660,14 @@
       </p:sp>
       <p:sp>
         <p:nvSpPr>
-          <p:cNvPr id="18" name="TextBox 17"/>
+          <p:cNvPr id="25" name="TextBox 24"/>
           <p:cNvSpPr txBox="1"/>
           <p:nvPr/>
         </p:nvSpPr>
         <p:spPr>
           <a:xfrm>
-            <a:off x="822960" y="5257800"/>
-            <a:ext cx="10607040" cy="914400"/>
+            <a:off x="8412480" y="4828032"/>
+            <a:ext cx="2971800" cy="384048"/>
           </a:xfrm>
           <a:prstGeom prst="rect">
             <a:avLst/>
@@ -5262,9 +5680,97 @@
           </a:bodyPr>
           <a:lstStyle/>
           <a:p>
+            <a:pPr algn="ctr">
+              <a:spcBef>
+                <a:spcPts val="0"/>
+              </a:spcBef>
+              <a:spcAft>
+                <a:spcPts val="0"/>
+              </a:spcAft>
+            </a:pPr>
+            <a:r>
+              <a:rPr sz="1100" b="1" i="0">
+                <a:solidFill>
+                  <a:srgbClr val="005EB8"/>
+                </a:solidFill>
+                <a:latin typeface="Arial"/>
+              </a:rPr>
+              <a:t>Target: 1 lakh families a month</a:t>
+            </a:r>
+          </a:p>
+        </p:txBody>
+      </p:sp>
+      <p:sp>
+        <p:nvSpPr>
+          <p:cNvPr id="26" name="Rounded Rectangle 25"/>
+          <p:cNvSpPr/>
+          <p:nvPr/>
+        </p:nvSpPr>
+        <p:spPr>
+          <a:xfrm>
+            <a:off x="548640" y="5532120"/>
+            <a:ext cx="11091672" cy="658368"/>
+          </a:xfrm>
+          <a:prstGeom prst="roundRect">
+            <a:avLst>
+              <a:gd name="adj" fmla="val 6000"/>
+            </a:avLst>
+          </a:prstGeom>
+          <a:solidFill>
+            <a:srgbClr val="E8F1FA"/>
+          </a:solidFill>
+          <a:ln>
+            <a:noFill/>
+          </a:ln>
+          <a:effectLst/>
+        </p:spPr>
+        <p:style>
+          <a:lnRef idx="1">
+            <a:schemeClr val="accent1"/>
+          </a:lnRef>
+          <a:fillRef idx="3">
+            <a:schemeClr val="accent1"/>
+          </a:fillRef>
+          <a:effectRef idx="2">
+            <a:schemeClr val="accent1"/>
+          </a:effectRef>
+          <a:fontRef idx="minor">
+            <a:schemeClr val="lt1"/>
+          </a:fontRef>
+        </p:style>
+        <p:txBody>
+          <a:bodyPr rtlCol="0" anchor="ctr"/>
+          <a:lstStyle/>
+          <a:p>
+            <a:pPr algn="ctr"/>
+          </a:p>
+        </p:txBody>
+      </p:sp>
+      <p:sp>
+        <p:nvSpPr>
+          <p:cNvPr id="27" name="TextBox 26"/>
+          <p:cNvSpPr txBox="1"/>
+          <p:nvPr/>
+        </p:nvSpPr>
+        <p:spPr>
+          <a:xfrm>
+            <a:off x="822960" y="5532120"/>
+            <a:ext cx="10607040" cy="658368"/>
+          </a:xfrm>
+          <a:prstGeom prst="rect">
+            <a:avLst/>
+          </a:prstGeom>
+          <a:noFill/>
+        </p:spPr>
+        <p:txBody>
+          <a:bodyPr wrap="square" lIns="0" rIns="0" tIns="0" bIns="0" anchor="ctr">
+            <a:spAutoFit/>
+          </a:bodyPr>
+          <a:lstStyle/>
+          <a:p>
             <a:pPr algn="l">
               <a:lnSpc>
-                <a:spcPct val="125000"/>
+                <a:spcPct val="120000"/>
               </a:lnSpc>
               <a:spcBef>
                 <a:spcPts val="0"/>
@@ -5274,7 +5780,7 @@
               </a:spcAft>
             </a:pPr>
             <a:r>
-              <a:rPr sz="1300" b="1" i="0">
+              <a:rPr sz="1250" b="1" i="0">
                 <a:solidFill>
                   <a:srgbClr val="005EB8"/>
                 </a:solidFill>
@@ -5283,13 +5789,13 @@
               <a:t>Already in place: </a:t>
             </a:r>
             <a:r>
-              <a:rPr sz="1300" b="0" i="0">
+              <a:rPr sz="1250" b="0" i="0">
                 <a:solidFill>
                   <a:srgbClr val="14181C"/>
                 </a:solidFill>
                 <a:latin typeface="Arial"/>
               </a:rPr>
-              <a:t>all 1,949 government treatment prices are loaded, the estimator retrains itself, and the chat assistant learns from every saved session.</a:t>
+              <a:t>1,949 government treatment prices loaded · the estimator retrains itself · the chat assistant remembers saved sessions · English and Hindi · light and dark themes.</a:t>
             </a:r>
           </a:p>
         </p:txBody>
@@ -9408,7 +9914,7 @@
                 </a:solidFill>
                 <a:latin typeface="Arial"/>
               </a:rPr>
-              <a:t>Works without uploading anything — the policy PDF is optional.</a:t>
+              <a:t>English and Hindi on every page, switched with one button; light and dark themes.</a:t>
             </a:r>
           </a:p>
           <a:p>
@@ -9436,7 +9942,7 @@
                 </a:solidFill>
                 <a:latin typeface="Arial"/>
               </a:rPr>
-              <a:t>Next: Hindi and regional languages, voice questions, screen-reader checks.</a:t>
+              <a:t>Next: more Indian languages, voice questions, screen-reader checks.</a:t>
             </a:r>
           </a:p>
         </p:txBody>
@@ -10246,8 +10752,8 @@
           <p:nvPr/>
         </p:nvGraphicFramePr>
         <p:xfrm>
-          <a:off x="457200" y="1371600"/>
-          <a:ext cx="5852160" cy="4023360"/>
+          <a:off x="411480" y="1325880"/>
+          <a:ext cx="5989320" cy="4114800"/>
         </p:xfrm>
         <a:graphic>
           <a:graphicData uri="http://schemas.openxmlformats.org/drawingml/2006/chart">
@@ -12225,7 +12731,7 @@
                 </a:solidFill>
                 <a:latin typeface="Rockwell"/>
               </a:rPr>
-              <a:t>What ClaimCast costs to run</a:t>
+              <a:t>What each answer costs</a:t>
             </a:r>
           </a:p>
         </p:txBody>
@@ -12267,7 +12773,7 @@
                 </a:solidFill>
                 <a:latin typeface="Arial"/>
               </a:rPr>
-              <a:t>Measured on the working prototype</a:t>
+              <a:t>Inference only — the cost of answering a family, measured on the working prototype</a:t>
             </a:r>
           </a:p>
         </p:txBody>
@@ -12280,8 +12786,8 @@
         </p:nvSpPr>
         <p:spPr>
           <a:xfrm>
-            <a:off x="548640" y="1417320"/>
-            <a:ext cx="2633472" cy="2514600"/>
+            <a:off x="548640" y="1371600"/>
+            <a:ext cx="2633472" cy="1965960"/>
           </a:xfrm>
           <a:prstGeom prst="roundRect">
             <a:avLst>
@@ -12328,8 +12834,8 @@
         </p:nvSpPr>
         <p:spPr>
           <a:xfrm>
-            <a:off x="777240" y="1645920"/>
-            <a:ext cx="2286000" cy="685800"/>
+            <a:off x="777240" y="1536192"/>
+            <a:ext cx="2286000" cy="640080"/>
           </a:xfrm>
           <a:prstGeom prst="rect">
             <a:avLst/>
@@ -12351,7 +12857,7 @@
               </a:spcAft>
             </a:pPr>
             <a:r>
-              <a:rPr sz="3400" b="1" i="0">
+              <a:rPr sz="3000" b="1" i="0">
                 <a:solidFill>
                   <a:srgbClr val="005EB8"/>
                 </a:solidFill>
@@ -12370,7 +12876,7 @@
         </p:nvSpPr>
         <p:spPr>
           <a:xfrm>
-            <a:off x="777240" y="2331720"/>
+            <a:off x="777240" y="2176272"/>
             <a:ext cx="2286000" cy="320040"/>
           </a:xfrm>
           <a:prstGeom prst="rect">
@@ -12412,8 +12918,8 @@
         </p:nvSpPr>
         <p:spPr>
           <a:xfrm>
-            <a:off x="777240" y="2697480"/>
-            <a:ext cx="2240280" cy="1143000"/>
+            <a:off x="777240" y="2514600"/>
+            <a:ext cx="2240280" cy="777240"/>
           </a:xfrm>
           <a:prstGeom prst="rect">
             <a:avLst/>
@@ -12428,7 +12934,7 @@
           <a:p>
             <a:pPr algn="l">
               <a:lnSpc>
-                <a:spcPct val="125000"/>
+                <a:spcPct val="120000"/>
               </a:lnSpc>
               <a:spcBef>
                 <a:spcPts val="0"/>
@@ -12438,7 +12944,7 @@
               </a:spcAft>
             </a:pPr>
             <a:r>
-              <a:rPr sz="1150" b="0" i="0">
+              <a:rPr sz="1100" b="0" i="0">
                 <a:solidFill>
                   <a:srgbClr val="2B3138"/>
                 </a:solidFill>
@@ -12457,8 +12963,8 @@
         </p:nvSpPr>
         <p:spPr>
           <a:xfrm>
-            <a:off x="3364992" y="1417320"/>
-            <a:ext cx="2633472" cy="2514600"/>
+            <a:off x="3364992" y="1371600"/>
+            <a:ext cx="2633472" cy="1965960"/>
           </a:xfrm>
           <a:prstGeom prst="roundRect">
             <a:avLst>
@@ -12505,8 +13011,8 @@
         </p:nvSpPr>
         <p:spPr>
           <a:xfrm>
-            <a:off x="3593592" y="1645920"/>
-            <a:ext cx="2286000" cy="685800"/>
+            <a:off x="3593592" y="1536192"/>
+            <a:ext cx="2286000" cy="640080"/>
           </a:xfrm>
           <a:prstGeom prst="rect">
             <a:avLst/>
@@ -12528,13 +13034,13 @@
               </a:spcAft>
             </a:pPr>
             <a:r>
-              <a:rPr sz="3400" b="1" i="0">
+              <a:rPr sz="3000" b="1" i="0">
                 <a:solidFill>
                   <a:srgbClr val="005EB8"/>
                 </a:solidFill>
                 <a:latin typeface="Rockwell"/>
               </a:rPr>
-              <a:t>₹9–15</a:t>
+              <a:t>~5 paise</a:t>
             </a:r>
           </a:p>
         </p:txBody>
@@ -12547,7 +13053,7 @@
         </p:nvSpPr>
         <p:spPr>
           <a:xfrm>
-            <a:off x="3593592" y="2331720"/>
+            <a:off x="3593592" y="2176272"/>
             <a:ext cx="2286000" cy="320040"/>
           </a:xfrm>
           <a:prstGeom prst="rect">
@@ -12576,7 +13082,7 @@
                 </a:solidFill>
                 <a:latin typeface="Arial"/>
               </a:rPr>
-              <a:t>a month to host</a:t>
+              <a:t>per chat question</a:t>
             </a:r>
           </a:p>
         </p:txBody>
@@ -12589,8 +13095,8 @@
         </p:nvSpPr>
         <p:spPr>
           <a:xfrm>
-            <a:off x="3593592" y="2697480"/>
-            <a:ext cx="2240280" cy="1143000"/>
+            <a:off x="3593592" y="2514600"/>
+            <a:ext cx="2240280" cy="777240"/>
           </a:xfrm>
           <a:prstGeom prst="rect">
             <a:avLst/>
@@ -12605,7 +13111,7 @@
           <a:p>
             <a:pPr algn="l">
               <a:lnSpc>
-                <a:spcPct val="125000"/>
+                <a:spcPct val="120000"/>
               </a:lnSpc>
               <a:spcBef>
                 <a:spcPts val="0"/>
@@ -12615,13 +13121,13 @@
               </a:spcAft>
             </a:pPr>
             <a:r>
-              <a:rPr sz="1150" b="0" i="0">
+              <a:rPr sz="1100" b="0" i="0">
                 <a:solidFill>
                   <a:srgbClr val="2B3138"/>
                 </a:solidFill>
                 <a:latin typeface="Arial"/>
               </a:rPr>
-              <a:t>Runs on Google Cloud free tiers; a ₹200 budget alert guards it.</a:t>
+              <a:t>Llama 3.3 70B through OpenRouter, measured on our own usage.</a:t>
             </a:r>
           </a:p>
         </p:txBody>
@@ -12634,8 +13140,8 @@
         </p:nvSpPr>
         <p:spPr>
           <a:xfrm>
-            <a:off x="6181344" y="1417320"/>
-            <a:ext cx="2633472" cy="2514600"/>
+            <a:off x="6181344" y="1371600"/>
+            <a:ext cx="2633472" cy="1965960"/>
           </a:xfrm>
           <a:prstGeom prst="roundRect">
             <a:avLst>
@@ -12682,8 +13188,8 @@
         </p:nvSpPr>
         <p:spPr>
           <a:xfrm>
-            <a:off x="6409944" y="1645920"/>
-            <a:ext cx="2286000" cy="685800"/>
+            <a:off x="6409944" y="1536192"/>
+            <a:ext cx="2286000" cy="640080"/>
           </a:xfrm>
           <a:prstGeom prst="rect">
             <a:avLst/>
@@ -12705,13 +13211,13 @@
               </a:spcAft>
             </a:pPr>
             <a:r>
-              <a:rPr sz="3400" b="1" i="0">
+              <a:rPr sz="3000" b="1" i="0">
                 <a:solidFill>
                   <a:srgbClr val="005EB8"/>
                 </a:solidFill>
                 <a:latin typeface="Rockwell"/>
               </a:rPr>
-              <a:t>~5 paise</a:t>
+              <a:t>≈ ₹0</a:t>
             </a:r>
           </a:p>
         </p:txBody>
@@ -12724,7 +13230,7 @@
         </p:nvSpPr>
         <p:spPr>
           <a:xfrm>
-            <a:off x="6409944" y="2331720"/>
+            <a:off x="6409944" y="2176272"/>
             <a:ext cx="2286000" cy="320040"/>
           </a:xfrm>
           <a:prstGeom prst="rect">
@@ -12753,7 +13259,7 @@
                 </a:solidFill>
                 <a:latin typeface="Arial"/>
               </a:rPr>
-              <a:t>per chat question</a:t>
+              <a:t>per bill estimate</a:t>
             </a:r>
           </a:p>
         </p:txBody>
@@ -12766,8 +13272,8 @@
         </p:nvSpPr>
         <p:spPr>
           <a:xfrm>
-            <a:off x="6409944" y="2697480"/>
-            <a:ext cx="2240280" cy="1143000"/>
+            <a:off x="6409944" y="2514600"/>
+            <a:ext cx="2240280" cy="777240"/>
           </a:xfrm>
           <a:prstGeom prst="rect">
             <a:avLst/>
@@ -12782,7 +13288,7 @@
           <a:p>
             <a:pPr algn="l">
               <a:lnSpc>
-                <a:spcPct val="125000"/>
+                <a:spcPct val="120000"/>
               </a:lnSpc>
               <a:spcBef>
                 <a:spcPts val="0"/>
@@ -12792,13 +13298,13 @@
               </a:spcAft>
             </a:pPr>
             <a:r>
-              <a:rPr sz="1150" b="0" i="0">
+              <a:rPr sz="1100" b="0" i="0">
                 <a:solidFill>
                   <a:srgbClr val="2B3138"/>
                 </a:solidFill>
                 <a:latin typeface="Arial"/>
               </a:rPr>
-              <a:t>Llama 3.3 70B through OpenRouter — measured on our own usage.</a:t>
+              <a:t>The estimator answers in about 1 millisecond on an ordinary CPU.</a:t>
             </a:r>
           </a:p>
         </p:txBody>
@@ -12811,8 +13317,8 @@
         </p:nvSpPr>
         <p:spPr>
           <a:xfrm>
-            <a:off x="8997696" y="1417320"/>
-            <a:ext cx="2633472" cy="2514600"/>
+            <a:off x="8997696" y="1371600"/>
+            <a:ext cx="2633472" cy="1965960"/>
           </a:xfrm>
           <a:prstGeom prst="roundRect">
             <a:avLst>
@@ -12859,8 +13365,8 @@
         </p:nvSpPr>
         <p:spPr>
           <a:xfrm>
-            <a:off x="9226296" y="1645920"/>
-            <a:ext cx="2286000" cy="685800"/>
+            <a:off x="9226296" y="1536192"/>
+            <a:ext cx="2286000" cy="640080"/>
           </a:xfrm>
           <a:prstGeom prst="rect">
             <a:avLst/>
@@ -12882,7 +13388,7 @@
               </a:spcAft>
             </a:pPr>
             <a:r>
-              <a:rPr sz="3400" b="1" i="0">
+              <a:rPr sz="3000" b="1" i="0">
                 <a:solidFill>
                   <a:srgbClr val="005EB8"/>
                 </a:solidFill>
@@ -12901,7 +13407,7 @@
         </p:nvSpPr>
         <p:spPr>
           <a:xfrm>
-            <a:off x="9226296" y="2331720"/>
+            <a:off x="9226296" y="2176272"/>
             <a:ext cx="2286000" cy="320040"/>
           </a:xfrm>
           <a:prstGeom prst="rect">
@@ -12943,8 +13449,8 @@
         </p:nvSpPr>
         <p:spPr>
           <a:xfrm>
-            <a:off x="9226296" y="2697480"/>
-            <a:ext cx="2240280" cy="1143000"/>
+            <a:off x="9226296" y="2514600"/>
+            <a:ext cx="2240280" cy="777240"/>
           </a:xfrm>
           <a:prstGeom prst="rect">
             <a:avLst/>
@@ -12959,7 +13465,7 @@
           <a:p>
             <a:pPr algn="l">
               <a:lnSpc>
-                <a:spcPct val="125000"/>
+                <a:spcPct val="120000"/>
               </a:lnSpc>
               <a:spcBef>
                 <a:spcPts val="0"/>
@@ -12969,7 +13475,7 @@
               </a:spcAft>
             </a:pPr>
             <a:r>
-              <a:rPr sz="1150" b="0" i="0">
+              <a:rPr sz="1100" b="0" i="0">
                 <a:solidFill>
                   <a:srgbClr val="2B3138"/>
                 </a:solidFill>
@@ -12982,14 +13488,622 @@
       </p:sp>
       <p:sp>
         <p:nvSpPr>
-          <p:cNvPr id="22" name="Rounded Rectangle 21"/>
+          <p:cNvPr id="22" name="TextBox 21"/>
+          <p:cNvSpPr txBox="1"/>
+          <p:nvPr/>
+        </p:nvSpPr>
+        <p:spPr>
+          <a:xfrm>
+            <a:off x="548640" y="3566160"/>
+            <a:ext cx="7315200" cy="320040"/>
+          </a:xfrm>
+          <a:prstGeom prst="rect">
+            <a:avLst/>
+          </a:prstGeom>
+          <a:noFill/>
+        </p:spPr>
+        <p:txBody>
+          <a:bodyPr wrap="square" lIns="0" rIns="0" tIns="0" bIns="0" anchor="t">
+            <a:spAutoFit/>
+          </a:bodyPr>
+          <a:lstStyle/>
+          <a:p>
+            <a:pPr algn="l">
+              <a:spcBef>
+                <a:spcPts val="0"/>
+              </a:spcBef>
+              <a:spcAft>
+                <a:spcPts val="0"/>
+              </a:spcAft>
+            </a:pPr>
+            <a:r>
+              <a:rPr sz="1100" b="1" i="0">
+                <a:solidFill>
+                  <a:srgbClr val="005EB8"/>
+                </a:solidFill>
+                <a:latin typeface="Arial"/>
+              </a:rPr>
+              <a:t>IF WE SCALE UP  ·  5 chat questions and 20 bill estimates per family</a:t>
+            </a:r>
+          </a:p>
+        </p:txBody>
+      </p:sp>
+      <p:graphicFrame>
+        <p:nvGraphicFramePr>
+          <p:cNvPr id="23" name="Table 22"/>
+          <p:cNvGraphicFramePr>
+            <a:graphicFrameLocks noGrp="1"/>
+          </p:cNvGraphicFramePr>
+          <p:nvPr/>
+        </p:nvGraphicFramePr>
+        <p:xfrm>
+          <a:off x="548640" y="3931920"/>
+          <a:ext cx="7406640" cy="2121408"/>
+        </p:xfrm>
+        <a:graphic>
+          <a:graphicData uri="http://schemas.openxmlformats.org/drawingml/2006/table">
+            <a:tbl>
+              <a:tblPr firstRow="1" bandRow="1">
+                <a:tableStyleId>{5C22544A-7EE6-4342-B048-85BDC9FD1C3A}</a:tableStyleId>
+              </a:tblPr>
+              <a:tblGrid>
+                <a:gridCol w="1417320"/>
+                <a:gridCol w="1280160"/>
+                <a:gridCol w="1143000"/>
+                <a:gridCol w="1234440"/>
+                <a:gridCol w="1234440"/>
+                <a:gridCol w="1097280"/>
+              </a:tblGrid>
+              <a:tr h="475488">
+                <a:tc>
+                  <a:txBody>
+                    <a:bodyPr/>
+                    <a:lstStyle/>
+                    <a:p>
+                      <a:r>
+                        <a:rPr sz="1100" b="1">
+                          <a:solidFill>
+                            <a:srgbClr val="FFFFFF"/>
+                          </a:solidFill>
+                          <a:latin typeface="Arial"/>
+                        </a:rPr>
+                        <a:t>Families a month</a:t>
+                      </a:r>
+                    </a:p>
+                  </a:txBody>
+                  <a:tcPr marL="109728" marR="109728" anchor="ctr">
+                    <a:solidFill>
+                      <a:srgbClr val="14181C"/>
+                    </a:solidFill>
+                  </a:tcPr>
+                </a:tc>
+                <a:tc>
+                  <a:txBody>
+                    <a:bodyPr/>
+                    <a:lstStyle/>
+                    <a:p>
+                      <a:r>
+                        <a:rPr sz="1100" b="1">
+                          <a:solidFill>
+                            <a:srgbClr val="FFFFFF"/>
+                          </a:solidFill>
+                          <a:latin typeface="Arial"/>
+                        </a:rPr>
+                        <a:t>Chat questions</a:t>
+                      </a:r>
+                    </a:p>
+                  </a:txBody>
+                  <a:tcPr marL="109728" marR="109728" anchor="ctr">
+                    <a:solidFill>
+                      <a:srgbClr val="14181C"/>
+                    </a:solidFill>
+                  </a:tcPr>
+                </a:tc>
+                <a:tc>
+                  <a:txBody>
+                    <a:bodyPr/>
+                    <a:lstStyle/>
+                    <a:p>
+                      <a:r>
+                        <a:rPr sz="1100" b="1">
+                          <a:solidFill>
+                            <a:srgbClr val="FFFFFF"/>
+                          </a:solidFill>
+                          <a:latin typeface="Arial"/>
+                        </a:rPr>
+                        <a:t>Chat cost</a:t>
+                      </a:r>
+                    </a:p>
+                  </a:txBody>
+                  <a:tcPr marL="109728" marR="109728" anchor="ctr">
+                    <a:solidFill>
+                      <a:srgbClr val="14181C"/>
+                    </a:solidFill>
+                  </a:tcPr>
+                </a:tc>
+                <a:tc>
+                  <a:txBody>
+                    <a:bodyPr/>
+                    <a:lstStyle/>
+                    <a:p>
+                      <a:r>
+                        <a:rPr sz="1100" b="1">
+                          <a:solidFill>
+                            <a:srgbClr val="FFFFFF"/>
+                          </a:solidFill>
+                          <a:latin typeface="Arial"/>
+                        </a:rPr>
+                        <a:t>Bill estimates</a:t>
+                      </a:r>
+                    </a:p>
+                  </a:txBody>
+                  <a:tcPr marL="109728" marR="109728" anchor="ctr">
+                    <a:solidFill>
+                      <a:srgbClr val="14181C"/>
+                    </a:solidFill>
+                  </a:tcPr>
+                </a:tc>
+                <a:tc>
+                  <a:txBody>
+                    <a:bodyPr/>
+                    <a:lstStyle/>
+                    <a:p>
+                      <a:r>
+                        <a:rPr sz="1100" b="1">
+                          <a:solidFill>
+                            <a:srgbClr val="FFFFFF"/>
+                          </a:solidFill>
+                          <a:latin typeface="Arial"/>
+                        </a:rPr>
+                        <a:t>Total a month</a:t>
+                      </a:r>
+                    </a:p>
+                  </a:txBody>
+                  <a:tcPr marL="109728" marR="109728" anchor="ctr">
+                    <a:solidFill>
+                      <a:srgbClr val="14181C"/>
+                    </a:solidFill>
+                  </a:tcPr>
+                </a:tc>
+                <a:tc>
+                  <a:txBody>
+                    <a:bodyPr/>
+                    <a:lstStyle/>
+                    <a:p>
+                      <a:r>
+                        <a:rPr sz="1100" b="1">
+                          <a:solidFill>
+                            <a:srgbClr val="FFFFFF"/>
+                          </a:solidFill>
+                          <a:latin typeface="Arial"/>
+                        </a:rPr>
+                        <a:t>Per family</a:t>
+                      </a:r>
+                    </a:p>
+                  </a:txBody>
+                  <a:tcPr marL="109728" marR="109728" anchor="ctr">
+                    <a:solidFill>
+                      <a:srgbClr val="14181C"/>
+                    </a:solidFill>
+                  </a:tcPr>
+                </a:tc>
+              </a:tr>
+              <a:tr h="548640">
+                <a:tc>
+                  <a:txBody>
+                    <a:bodyPr/>
+                    <a:lstStyle/>
+                    <a:p>
+                      <a:r>
+                        <a:rPr sz="1300" b="1">
+                          <a:solidFill>
+                            <a:srgbClr val="14181C"/>
+                          </a:solidFill>
+                          <a:latin typeface="Arial"/>
+                        </a:rPr>
+                        <a:t>1,000</a:t>
+                      </a:r>
+                    </a:p>
+                  </a:txBody>
+                  <a:tcPr marL="109728" marR="109728" anchor="ctr">
+                    <a:solidFill>
+                      <a:srgbClr val="FFFFFF"/>
+                    </a:solidFill>
+                  </a:tcPr>
+                </a:tc>
+                <a:tc>
+                  <a:txBody>
+                    <a:bodyPr/>
+                    <a:lstStyle/>
+                    <a:p>
+                      <a:r>
+                        <a:rPr sz="1300" b="0">
+                          <a:solidFill>
+                            <a:srgbClr val="14181C"/>
+                          </a:solidFill>
+                          <a:latin typeface="Arial"/>
+                        </a:rPr>
+                        <a:t>5,000</a:t>
+                      </a:r>
+                    </a:p>
+                  </a:txBody>
+                  <a:tcPr marL="109728" marR="109728" anchor="ctr">
+                    <a:solidFill>
+                      <a:srgbClr val="FFFFFF"/>
+                    </a:solidFill>
+                  </a:tcPr>
+                </a:tc>
+                <a:tc>
+                  <a:txBody>
+                    <a:bodyPr/>
+                    <a:lstStyle/>
+                    <a:p>
+                      <a:r>
+                        <a:rPr sz="1300" b="0">
+                          <a:solidFill>
+                            <a:srgbClr val="14181C"/>
+                          </a:solidFill>
+                          <a:latin typeface="Arial"/>
+                        </a:rPr>
+                        <a:t>₹220</a:t>
+                      </a:r>
+                    </a:p>
+                  </a:txBody>
+                  <a:tcPr marL="109728" marR="109728" anchor="ctr">
+                    <a:solidFill>
+                      <a:srgbClr val="FFFFFF"/>
+                    </a:solidFill>
+                  </a:tcPr>
+                </a:tc>
+                <a:tc>
+                  <a:txBody>
+                    <a:bodyPr/>
+                    <a:lstStyle/>
+                    <a:p>
+                      <a:r>
+                        <a:rPr sz="1300" b="0">
+                          <a:solidFill>
+                            <a:srgbClr val="14181C"/>
+                          </a:solidFill>
+                          <a:latin typeface="Arial"/>
+                        </a:rPr>
+                        <a:t>&lt; ₹1</a:t>
+                      </a:r>
+                    </a:p>
+                  </a:txBody>
+                  <a:tcPr marL="109728" marR="109728" anchor="ctr">
+                    <a:solidFill>
+                      <a:srgbClr val="FFFFFF"/>
+                    </a:solidFill>
+                  </a:tcPr>
+                </a:tc>
+                <a:tc>
+                  <a:txBody>
+                    <a:bodyPr/>
+                    <a:lstStyle/>
+                    <a:p>
+                      <a:r>
+                        <a:rPr sz="1300" b="1">
+                          <a:solidFill>
+                            <a:srgbClr val="005EB8"/>
+                          </a:solidFill>
+                          <a:latin typeface="Arial"/>
+                        </a:rPr>
+                        <a:t>₹220</a:t>
+                      </a:r>
+                    </a:p>
+                  </a:txBody>
+                  <a:tcPr marL="109728" marR="109728" anchor="ctr">
+                    <a:solidFill>
+                      <a:srgbClr val="FFFFFF"/>
+                    </a:solidFill>
+                  </a:tcPr>
+                </a:tc>
+                <a:tc>
+                  <a:txBody>
+                    <a:bodyPr/>
+                    <a:lstStyle/>
+                    <a:p>
+                      <a:r>
+                        <a:rPr sz="1300" b="0">
+                          <a:solidFill>
+                            <a:srgbClr val="14181C"/>
+                          </a:solidFill>
+                          <a:latin typeface="Arial"/>
+                        </a:rPr>
+                        <a:t>22 paise</a:t>
+                      </a:r>
+                    </a:p>
+                  </a:txBody>
+                  <a:tcPr marL="109728" marR="109728" anchor="ctr">
+                    <a:solidFill>
+                      <a:srgbClr val="FFFFFF"/>
+                    </a:solidFill>
+                  </a:tcPr>
+                </a:tc>
+              </a:tr>
+              <a:tr h="548640">
+                <a:tc>
+                  <a:txBody>
+                    <a:bodyPr/>
+                    <a:lstStyle/>
+                    <a:p>
+                      <a:r>
+                        <a:rPr sz="1300" b="1">
+                          <a:solidFill>
+                            <a:srgbClr val="14181C"/>
+                          </a:solidFill>
+                          <a:latin typeface="Arial"/>
+                        </a:rPr>
+                        <a:t>1 lakh</a:t>
+                      </a:r>
+                    </a:p>
+                  </a:txBody>
+                  <a:tcPr marL="109728" marR="109728" anchor="ctr">
+                    <a:solidFill>
+                      <a:srgbClr val="F4F7FA"/>
+                    </a:solidFill>
+                  </a:tcPr>
+                </a:tc>
+                <a:tc>
+                  <a:txBody>
+                    <a:bodyPr/>
+                    <a:lstStyle/>
+                    <a:p>
+                      <a:r>
+                        <a:rPr sz="1300" b="0">
+                          <a:solidFill>
+                            <a:srgbClr val="14181C"/>
+                          </a:solidFill>
+                          <a:latin typeface="Arial"/>
+                        </a:rPr>
+                        <a:t>5 lakh</a:t>
+                      </a:r>
+                    </a:p>
+                  </a:txBody>
+                  <a:tcPr marL="109728" marR="109728" anchor="ctr">
+                    <a:solidFill>
+                      <a:srgbClr val="F4F7FA"/>
+                    </a:solidFill>
+                  </a:tcPr>
+                </a:tc>
+                <a:tc>
+                  <a:txBody>
+                    <a:bodyPr/>
+                    <a:lstStyle/>
+                    <a:p>
+                      <a:r>
+                        <a:rPr sz="1300" b="0">
+                          <a:solidFill>
+                            <a:srgbClr val="14181C"/>
+                          </a:solidFill>
+                          <a:latin typeface="Arial"/>
+                        </a:rPr>
+                        <a:t>₹22,000</a:t>
+                      </a:r>
+                    </a:p>
+                  </a:txBody>
+                  <a:tcPr marL="109728" marR="109728" anchor="ctr">
+                    <a:solidFill>
+                      <a:srgbClr val="F4F7FA"/>
+                    </a:solidFill>
+                  </a:tcPr>
+                </a:tc>
+                <a:tc>
+                  <a:txBody>
+                    <a:bodyPr/>
+                    <a:lstStyle/>
+                    <a:p>
+                      <a:r>
+                        <a:rPr sz="1300" b="0">
+                          <a:solidFill>
+                            <a:srgbClr val="14181C"/>
+                          </a:solidFill>
+                          <a:latin typeface="Arial"/>
+                        </a:rPr>
+                        <a:t>₹8</a:t>
+                      </a:r>
+                    </a:p>
+                  </a:txBody>
+                  <a:tcPr marL="109728" marR="109728" anchor="ctr">
+                    <a:solidFill>
+                      <a:srgbClr val="F4F7FA"/>
+                    </a:solidFill>
+                  </a:tcPr>
+                </a:tc>
+                <a:tc>
+                  <a:txBody>
+                    <a:bodyPr/>
+                    <a:lstStyle/>
+                    <a:p>
+                      <a:r>
+                        <a:rPr sz="1300" b="1">
+                          <a:solidFill>
+                            <a:srgbClr val="005EB8"/>
+                          </a:solidFill>
+                          <a:latin typeface="Arial"/>
+                        </a:rPr>
+                        <a:t>₹22,008</a:t>
+                      </a:r>
+                    </a:p>
+                  </a:txBody>
+                  <a:tcPr marL="109728" marR="109728" anchor="ctr">
+                    <a:solidFill>
+                      <a:srgbClr val="F4F7FA"/>
+                    </a:solidFill>
+                  </a:tcPr>
+                </a:tc>
+                <a:tc>
+                  <a:txBody>
+                    <a:bodyPr/>
+                    <a:lstStyle/>
+                    <a:p>
+                      <a:r>
+                        <a:rPr sz="1300" b="0">
+                          <a:solidFill>
+                            <a:srgbClr val="14181C"/>
+                          </a:solidFill>
+                          <a:latin typeface="Arial"/>
+                        </a:rPr>
+                        <a:t>22 paise</a:t>
+                      </a:r>
+                    </a:p>
+                  </a:txBody>
+                  <a:tcPr marL="109728" marR="109728" anchor="ctr">
+                    <a:solidFill>
+                      <a:srgbClr val="F4F7FA"/>
+                    </a:solidFill>
+                  </a:tcPr>
+                </a:tc>
+              </a:tr>
+              <a:tr h="548640">
+                <a:tc>
+                  <a:txBody>
+                    <a:bodyPr/>
+                    <a:lstStyle/>
+                    <a:p>
+                      <a:r>
+                        <a:rPr sz="1300" b="1">
+                          <a:solidFill>
+                            <a:srgbClr val="14181C"/>
+                          </a:solidFill>
+                          <a:latin typeface="Arial"/>
+                        </a:rPr>
+                        <a:t>10 lakh</a:t>
+                      </a:r>
+                    </a:p>
+                  </a:txBody>
+                  <a:tcPr marL="109728" marR="109728" anchor="ctr">
+                    <a:solidFill>
+                      <a:srgbClr val="FFFFFF"/>
+                    </a:solidFill>
+                  </a:tcPr>
+                </a:tc>
+                <a:tc>
+                  <a:txBody>
+                    <a:bodyPr/>
+                    <a:lstStyle/>
+                    <a:p>
+                      <a:r>
+                        <a:rPr sz="1300" b="0">
+                          <a:solidFill>
+                            <a:srgbClr val="14181C"/>
+                          </a:solidFill>
+                          <a:latin typeface="Arial"/>
+                        </a:rPr>
+                        <a:t>50 lakh</a:t>
+                      </a:r>
+                    </a:p>
+                  </a:txBody>
+                  <a:tcPr marL="109728" marR="109728" anchor="ctr">
+                    <a:solidFill>
+                      <a:srgbClr val="FFFFFF"/>
+                    </a:solidFill>
+                  </a:tcPr>
+                </a:tc>
+                <a:tc>
+                  <a:txBody>
+                    <a:bodyPr/>
+                    <a:lstStyle/>
+                    <a:p>
+                      <a:r>
+                        <a:rPr sz="1300" b="0">
+                          <a:solidFill>
+                            <a:srgbClr val="14181C"/>
+                          </a:solidFill>
+                          <a:latin typeface="Arial"/>
+                        </a:rPr>
+                        <a:t>₹2,20,000</a:t>
+                      </a:r>
+                    </a:p>
+                  </a:txBody>
+                  <a:tcPr marL="109728" marR="109728" anchor="ctr">
+                    <a:solidFill>
+                      <a:srgbClr val="FFFFFF"/>
+                    </a:solidFill>
+                  </a:tcPr>
+                </a:tc>
+                <a:tc>
+                  <a:txBody>
+                    <a:bodyPr/>
+                    <a:lstStyle/>
+                    <a:p>
+                      <a:r>
+                        <a:rPr sz="1300" b="0">
+                          <a:solidFill>
+                            <a:srgbClr val="14181C"/>
+                          </a:solidFill>
+                          <a:latin typeface="Arial"/>
+                        </a:rPr>
+                        <a:t>₹84</a:t>
+                      </a:r>
+                    </a:p>
+                  </a:txBody>
+                  <a:tcPr marL="109728" marR="109728" anchor="ctr">
+                    <a:solidFill>
+                      <a:srgbClr val="FFFFFF"/>
+                    </a:solidFill>
+                  </a:tcPr>
+                </a:tc>
+                <a:tc>
+                  <a:txBody>
+                    <a:bodyPr/>
+                    <a:lstStyle/>
+                    <a:p>
+                      <a:r>
+                        <a:rPr sz="1300" b="1">
+                          <a:solidFill>
+                            <a:srgbClr val="005EB8"/>
+                          </a:solidFill>
+                          <a:latin typeface="Arial"/>
+                        </a:rPr>
+                        <a:t>₹2,20,084</a:t>
+                      </a:r>
+                    </a:p>
+                  </a:txBody>
+                  <a:tcPr marL="109728" marR="109728" anchor="ctr">
+                    <a:solidFill>
+                      <a:srgbClr val="FFFFFF"/>
+                    </a:solidFill>
+                  </a:tcPr>
+                </a:tc>
+                <a:tc>
+                  <a:txBody>
+                    <a:bodyPr/>
+                    <a:lstStyle/>
+                    <a:p>
+                      <a:r>
+                        <a:rPr sz="1300" b="0">
+                          <a:solidFill>
+                            <a:srgbClr val="14181C"/>
+                          </a:solidFill>
+                          <a:latin typeface="Arial"/>
+                        </a:rPr>
+                        <a:t>22 paise</a:t>
+                      </a:r>
+                    </a:p>
+                  </a:txBody>
+                  <a:tcPr marL="109728" marR="109728" anchor="ctr">
+                    <a:solidFill>
+                      <a:srgbClr val="FFFFFF"/>
+                    </a:solidFill>
+                  </a:tcPr>
+                </a:tc>
+              </a:tr>
+            </a:tbl>
+          </a:graphicData>
+        </a:graphic>
+      </p:graphicFrame>
+      <p:sp>
+        <p:nvSpPr>
+          <p:cNvPr id="24" name="Rounded Rectangle 23"/>
           <p:cNvSpPr/>
           <p:nvPr/>
         </p:nvSpPr>
         <p:spPr>
           <a:xfrm>
-            <a:off x="548640" y="4251960"/>
-            <a:ext cx="11091672" cy="1920240"/>
+            <a:off x="8229600" y="3611880"/>
+            <a:ext cx="3410712" cy="2514600"/>
           </a:xfrm>
           <a:prstGeom prst="roundRect">
             <a:avLst>
@@ -13028,14 +14142,14 @@
       </p:sp>
       <p:sp>
         <p:nvSpPr>
-          <p:cNvPr id="23" name="TextBox 22"/>
+          <p:cNvPr id="25" name="TextBox 24"/>
           <p:cNvSpPr txBox="1"/>
           <p:nvPr/>
         </p:nvSpPr>
         <p:spPr>
           <a:xfrm>
-            <a:off x="868680" y="4434840"/>
-            <a:ext cx="5029200" cy="1554480"/>
+            <a:off x="8503920" y="3794760"/>
+            <a:ext cx="2926080" cy="2194560"/>
           </a:xfrm>
           <a:prstGeom prst="rect">
             <a:avLst/>
@@ -13053,17 +14167,17 @@
                 <a:spcPts val="0"/>
               </a:spcBef>
               <a:spcAft>
-                <a:spcPts val="200"/>
-              </a:spcAft>
-            </a:pPr>
-            <a:r>
-              <a:rPr sz="4400" b="1" i="0">
+                <a:spcPts val="400"/>
+              </a:spcAft>
+            </a:pPr>
+            <a:r>
+              <a:rPr sz="3600" b="1" i="0">
                 <a:solidFill>
                   <a:srgbClr val="FFFFFF"/>
                 </a:solidFill>
                 <a:latin typeface="Rockwell"/>
               </a:rPr>
-              <a:t>Under ₹1</a:t>
+              <a:t>~22 paise</a:t>
             </a:r>
           </a:p>
           <a:p>
@@ -13075,109 +14189,23 @@
                 <a:spcPts val="0"/>
               </a:spcBef>
               <a:spcAft>
-                <a:spcPts val="0"/>
-              </a:spcAft>
-            </a:pPr>
-            <a:r>
-              <a:rPr sz="1350" b="0" i="0">
+                <a:spcPts val="800"/>
+              </a:spcAft>
+            </a:pPr>
+            <a:r>
+              <a:rPr sz="1250" b="0" i="0">
                 <a:solidFill>
                   <a:srgbClr val="FFFFFF"/>
                 </a:solidFill>
                 <a:latin typeface="Arial"/>
               </a:rPr>
-              <a:t>to serve one family’s whole session, including five chat questions.</a:t>
-            </a:r>
-          </a:p>
-        </p:txBody>
-      </p:sp>
-      <p:sp>
-        <p:nvSpPr>
-          <p:cNvPr id="24" name="Rectangle 23"/>
-          <p:cNvSpPr/>
-          <p:nvPr/>
-        </p:nvSpPr>
-        <p:spPr>
-          <a:xfrm>
-            <a:off x="6172200" y="4572000"/>
-            <a:ext cx="13716" cy="1280160"/>
-          </a:xfrm>
-          <a:prstGeom prst="rect">
-            <a:avLst/>
-          </a:prstGeom>
-          <a:solidFill>
-            <a:srgbClr val="FFFFFF"/>
-          </a:solidFill>
-          <a:ln>
-            <a:noFill/>
-          </a:ln>
-          <a:effectLst/>
-        </p:spPr>
-        <p:style>
-          <a:lnRef idx="1">
-            <a:schemeClr val="accent1"/>
-          </a:lnRef>
-          <a:fillRef idx="3">
-            <a:schemeClr val="accent1"/>
-          </a:fillRef>
-          <a:effectRef idx="2">
-            <a:schemeClr val="accent1"/>
-          </a:effectRef>
-          <a:fontRef idx="minor">
-            <a:schemeClr val="lt1"/>
-          </a:fontRef>
-        </p:style>
-        <p:txBody>
-          <a:bodyPr rtlCol="0" anchor="ctr"/>
-          <a:lstStyle/>
-          <a:p>
-            <a:pPr algn="ctr"/>
-          </a:p>
-        </p:txBody>
-      </p:sp>
-      <p:sp>
-        <p:nvSpPr>
-          <p:cNvPr id="25" name="TextBox 24"/>
-          <p:cNvSpPr txBox="1"/>
-          <p:nvPr/>
-        </p:nvSpPr>
-        <p:spPr>
-          <a:xfrm>
-            <a:off x="6492240" y="4434840"/>
-            <a:ext cx="4937760" cy="1554480"/>
-          </a:xfrm>
-          <a:prstGeom prst="rect">
-            <a:avLst/>
-          </a:prstGeom>
-          <a:noFill/>
-        </p:spPr>
-        <p:txBody>
-          <a:bodyPr wrap="square" lIns="0" rIns="0" tIns="0" bIns="0" anchor="ctr">
-            <a:spAutoFit/>
-          </a:bodyPr>
-          <a:lstStyle/>
-          <a:p>
-            <a:pPr algn="l">
-              <a:spcBef>
-                <a:spcPts val="0"/>
-              </a:spcBef>
-              <a:spcAft>
-                <a:spcPts val="200"/>
-              </a:spcAft>
-            </a:pPr>
-            <a:r>
-              <a:rPr sz="4400" b="1" i="0">
-                <a:solidFill>
-                  <a:srgbClr val="FFFFFF"/>
-                </a:solidFill>
-                <a:latin typeface="Rockwell"/>
-              </a:rPr>
-              <a:t>₹78,400</a:t>
+              <a:t>per family, at any size — the cost grows in a straight line with use, with no big fixed cost.</a:t>
             </a:r>
           </a:p>
           <a:p>
             <a:pPr algn="l">
               <a:lnSpc>
-                <a:spcPct val="125000"/>
+                <a:spcPct val="120000"/>
               </a:lnSpc>
               <a:spcBef>
                 <a:spcPts val="0"/>
@@ -13187,13 +14215,13 @@
               </a:spcAft>
             </a:pPr>
             <a:r>
-              <a:rPr sz="1350" b="0" i="0">
+              <a:rPr sz="1200" b="1" i="0">
                 <a:solidFill>
                   <a:srgbClr val="FFFFFF"/>
                 </a:solidFill>
                 <a:latin typeface="Arial"/>
               </a:rPr>
-              <a:t>saved in our example admission by choosing the right room.</a:t>
+              <a:t>Against ₹78,400 saved in our example admission.</a:t>
             </a:r>
           </a:p>
         </p:txBody>

</xml_diff>